<commit_message>
docs: update setup deck — point clone URL to public github amm-toolkit (was legacy gitlab)
Co-Authored-By: Claude Opus 4.8 (1M context) <noreply@anthropic.com>
</commit_message>
<xml_diff>
--- a/docs/Agentic-Marketing-Mastermind-Setup-Guide.pptx
+++ b/docs/Agentic-Marketing-Mastermind-Setup-Guide.pptx
@@ -6350,7 +6350,7 @@
               </a:defRPr>
             </a:pPr>
             <a:r>
-              <a:t>gitlab.com/juan.villamil/agentic-mastermind</a:t>
+              <a:t>github.com/search-atlas-group/amm-toolkit</a:t>
             </a:r>
           </a:p>
         </p:txBody>
@@ -7443,7 +7443,7 @@
               </a:defRPr>
             </a:pPr>
             <a:r>
-              <a:t>Open Warp  →  cd ~/agency/agentic-mastermind  →  claude  →  /help</a:t>
+              <a:t>Open Warp  →  cd ~/agency/amm-toolkit  →  claude  →  /help</a:t>
             </a:r>
           </a:p>
         </p:txBody>
@@ -10068,7 +10068,7 @@
               </a:defRPr>
             </a:pPr>
             <a:r>
-              <a:t>git clone https://gitlab.com/juan.villamil/agentic-mastermind.git</a:t>
+              <a:t>git clone https://github.com/search-atlas-group/amm-toolkit.git</a:t>
             </a:r>
           </a:p>
         </p:txBody>
@@ -10104,7 +10104,7 @@
               </a:defRPr>
             </a:pPr>
             <a:r>
-              <a:t>cd agentic-mastermind</a:t>
+              <a:t>cd amm-toolkit</a:t>
             </a:r>
           </a:p>
         </p:txBody>
@@ -11012,7 +11012,7 @@
               </a:defRPr>
             </a:pPr>
             <a:r>
-              <a:t>Run this inside the agentic-mastermind</a:t>
+              <a:t>Run this inside the amm-toolkit</a:t>
             </a:r>
             <a:br/>
             <a:r>

</xml_diff>

<commit_message>
docs: trim setup deck — drop Launch & Set-Permissions slide (basics no longer needed), resequence steps
Co-Authored-By: Claude Opus 4.8 (1M context) <noreply@anthropic.com>
</commit_message>
<xml_diff>
--- a/docs/Agentic-Marketing-Mastermind-Setup-Guide.pptx
+++ b/docs/Agentic-Marketing-Mastermind-Setup-Guide.pptx
@@ -12,7 +12,6 @@
     <p:sldId id="260" r:id="rId6"/>
     <p:sldId id="261" r:id="rId7"/>
     <p:sldId id="262" r:id="rId8"/>
-    <p:sldId id="263" r:id="rId9"/>
     <p:sldId id="264" r:id="rId10"/>
     <p:sldId id="265" r:id="rId11"/>
     <p:sldId id="266" r:id="rId12"/>
@@ -10766,444 +10765,6 @@
 </p:sld>
 </file>
 
-<file path=ppt/slides/slide8.xml><?xml version="1.0" encoding="utf-8"?>
-<p:sld xmlns:a="http://schemas.openxmlformats.org/drawingml/2006/main" xmlns:r="http://schemas.openxmlformats.org/officeDocument/2006/relationships" xmlns:p="http://schemas.openxmlformats.org/presentationml/2006/main">
-  <p:cSld>
-    <p:bg>
-      <p:bgPr>
-        <a:solidFill>
-          <a:srgbClr val="0F172A"/>
-        </a:solidFill>
-        <a:effectLst/>
-      </p:bgPr>
-    </p:bg>
-    <p:spTree>
-      <p:nvGrpSpPr>
-        <p:cNvPr id="1" name=""/>
-        <p:cNvGrpSpPr/>
-        <p:nvPr/>
-      </p:nvGrpSpPr>
-      <p:grpSpPr>
-        <a:xfrm>
-          <a:off x="0" y="0"/>
-          <a:ext cx="0" cy="0"/>
-          <a:chOff x="0" y="0"/>
-          <a:chExt cx="0" cy="0"/>
-        </a:xfrm>
-      </p:grpSpPr>
-      <p:sp>
-        <p:nvSpPr>
-          <p:cNvPr id="2" name="TextBox 1"/>
-          <p:cNvSpPr txBox="1"/>
-          <p:nvPr/>
-        </p:nvSpPr>
-        <p:spPr>
-          <a:xfrm>
-            <a:off x="731520" y="365760"/>
-            <a:ext cx="1828800" cy="457200"/>
-          </a:xfrm>
-          <a:prstGeom prst="rect">
-            <a:avLst/>
-          </a:prstGeom>
-          <a:noFill/>
-        </p:spPr>
-        <p:txBody>
-          <a:bodyPr wrap="square">
-            <a:spAutoFit/>
-          </a:bodyPr>
-          <a:lstStyle/>
-          <a:p>
-            <a:pPr algn="l">
-              <a:defRPr sz="1800" b="1">
-                <a:solidFill>
-                  <a:srgbClr val="38BDF8"/>
-                </a:solidFill>
-                <a:latin typeface="Calibri"/>
-              </a:defRPr>
-            </a:pPr>
-            <a:r>
-              <a:t>Steps 7 &amp; 8</a:t>
-            </a:r>
-          </a:p>
-        </p:txBody>
-      </p:sp>
-      <p:sp>
-        <p:nvSpPr>
-          <p:cNvPr id="3" name="TextBox 2"/>
-          <p:cNvSpPr txBox="1"/>
-          <p:nvPr/>
-        </p:nvSpPr>
-        <p:spPr>
-          <a:xfrm>
-            <a:off x="731520" y="822960"/>
-            <a:ext cx="9144000" cy="731520"/>
-          </a:xfrm>
-          <a:prstGeom prst="rect">
-            <a:avLst/>
-          </a:prstGeom>
-          <a:noFill/>
-        </p:spPr>
-        <p:txBody>
-          <a:bodyPr wrap="square">
-            <a:spAutoFit/>
-          </a:bodyPr>
-          <a:lstStyle/>
-          <a:p>
-            <a:pPr algn="l">
-              <a:defRPr sz="3600" b="1">
-                <a:solidFill>
-                  <a:srgbClr val="FFFFFF"/>
-                </a:solidFill>
-                <a:latin typeface="Calibri"/>
-              </a:defRPr>
-            </a:pPr>
-            <a:r>
-              <a:t>Launch Claude Code &amp; Set Permissions</a:t>
-            </a:r>
-          </a:p>
-        </p:txBody>
-      </p:sp>
-      <p:sp>
-        <p:nvSpPr>
-          <p:cNvPr id="4" name="Rounded Rectangle 3"/>
-          <p:cNvSpPr/>
-          <p:nvPr/>
-        </p:nvSpPr>
-        <p:spPr>
-          <a:xfrm>
-            <a:off x="731520" y="1828800"/>
-            <a:ext cx="5029200" cy="4114800"/>
-          </a:xfrm>
-          <a:prstGeom prst="roundRect">
-            <a:avLst>
-              <a:gd name="adj" fmla="val 3000"/>
-            </a:avLst>
-          </a:prstGeom>
-          <a:solidFill>
-            <a:srgbClr val="1A243B"/>
-          </a:solidFill>
-          <a:ln>
-            <a:noFill/>
-          </a:ln>
-        </p:spPr>
-        <p:style>
-          <a:lnRef idx="1">
-            <a:schemeClr val="accent1"/>
-          </a:lnRef>
-          <a:fillRef idx="3">
-            <a:schemeClr val="accent1"/>
-          </a:fillRef>
-          <a:effectRef idx="2">
-            <a:schemeClr val="accent1"/>
-          </a:effectRef>
-          <a:fontRef idx="minor">
-            <a:schemeClr val="lt1"/>
-          </a:fontRef>
-        </p:style>
-        <p:txBody>
-          <a:bodyPr rtlCol="0" anchor="ctr"/>
-          <a:lstStyle/>
-          <a:p>
-            <a:pPr algn="ctr"/>
-            <a:endParaRPr/>
-          </a:p>
-        </p:txBody>
-      </p:sp>
-      <p:sp>
-        <p:nvSpPr>
-          <p:cNvPr id="5" name="TextBox 4"/>
-          <p:cNvSpPr txBox="1"/>
-          <p:nvPr/>
-        </p:nvSpPr>
-        <p:spPr>
-          <a:xfrm>
-            <a:off x="1097280" y="2011680"/>
-            <a:ext cx="4389120" cy="457200"/>
-          </a:xfrm>
-          <a:prstGeom prst="rect">
-            <a:avLst/>
-          </a:prstGeom>
-          <a:noFill/>
-        </p:spPr>
-        <p:txBody>
-          <a:bodyPr wrap="square">
-            <a:spAutoFit/>
-          </a:bodyPr>
-          <a:lstStyle/>
-          <a:p>
-            <a:pPr algn="l">
-              <a:defRPr sz="2000" b="1">
-                <a:solidFill>
-                  <a:srgbClr val="38BDF8"/>
-                </a:solidFill>
-                <a:latin typeface="Calibri"/>
-              </a:defRPr>
-            </a:pPr>
-            <a:r>
-              <a:t>Launch:</a:t>
-            </a:r>
-          </a:p>
-        </p:txBody>
-      </p:sp>
-      <p:sp>
-        <p:nvSpPr>
-          <p:cNvPr id="6" name="TextBox 5"/>
-          <p:cNvSpPr txBox="1"/>
-          <p:nvPr/>
-        </p:nvSpPr>
-        <p:spPr>
-          <a:xfrm>
-            <a:off x="1097280" y="2560320"/>
-            <a:ext cx="4389120" cy="457200"/>
-          </a:xfrm>
-          <a:prstGeom prst="rect">
-            <a:avLst/>
-          </a:prstGeom>
-          <a:noFill/>
-        </p:spPr>
-        <p:txBody>
-          <a:bodyPr wrap="square">
-            <a:spAutoFit/>
-          </a:bodyPr>
-          <a:lstStyle/>
-          <a:p>
-            <a:pPr algn="l">
-              <a:defRPr sz="2800" b="1">
-                <a:solidFill>
-                  <a:srgbClr val="38BDF8"/>
-                </a:solidFill>
-                <a:latin typeface="Courier New"/>
-              </a:defRPr>
-            </a:pPr>
-            <a:r>
-              <a:t>claude</a:t>
-            </a:r>
-          </a:p>
-        </p:txBody>
-      </p:sp>
-      <p:sp>
-        <p:nvSpPr>
-          <p:cNvPr id="7" name="TextBox 6"/>
-          <p:cNvSpPr txBox="1"/>
-          <p:nvPr/>
-        </p:nvSpPr>
-        <p:spPr>
-          <a:xfrm>
-            <a:off x="1097280" y="3200400"/>
-            <a:ext cx="4389120" cy="2286000"/>
-          </a:xfrm>
-          <a:prstGeom prst="rect">
-            <a:avLst/>
-          </a:prstGeom>
-          <a:noFill/>
-        </p:spPr>
-        <p:txBody>
-          <a:bodyPr wrap="square">
-            <a:spAutoFit/>
-          </a:bodyPr>
-          <a:lstStyle/>
-          <a:p>
-            <a:pPr algn="l">
-              <a:defRPr sz="1600" b="0">
-                <a:solidFill>
-                  <a:srgbClr val="E2E8F0"/>
-                </a:solidFill>
-                <a:latin typeface="Calibri"/>
-              </a:defRPr>
-            </a:pPr>
-            <a:r>
-              <a:t>Run this inside the amm-toolkit</a:t>
-            </a:r>
-            <a:br/>
-            <a:r>
-              <a:t>directory. Claude Code will start up</a:t>
-            </a:r>
-            <a:br/>
-            <a:r>
-              <a:t>and connect to SearchAtlas via MCP.</a:t>
-            </a:r>
-          </a:p>
-        </p:txBody>
-      </p:sp>
-      <p:sp>
-        <p:nvSpPr>
-          <p:cNvPr id="8" name="Rounded Rectangle 7"/>
-          <p:cNvSpPr/>
-          <p:nvPr/>
-        </p:nvSpPr>
-        <p:spPr>
-          <a:xfrm>
-            <a:off x="6217920" y="1828800"/>
-            <a:ext cx="5029200" cy="4114800"/>
-          </a:xfrm>
-          <a:prstGeom prst="roundRect">
-            <a:avLst>
-              <a:gd name="adj" fmla="val 3000"/>
-            </a:avLst>
-          </a:prstGeom>
-          <a:solidFill>
-            <a:srgbClr val="1A243B"/>
-          </a:solidFill>
-          <a:ln>
-            <a:noFill/>
-          </a:ln>
-        </p:spPr>
-        <p:style>
-          <a:lnRef idx="1">
-            <a:schemeClr val="accent1"/>
-          </a:lnRef>
-          <a:fillRef idx="3">
-            <a:schemeClr val="accent1"/>
-          </a:fillRef>
-          <a:effectRef idx="2">
-            <a:schemeClr val="accent1"/>
-          </a:effectRef>
-          <a:fontRef idx="minor">
-            <a:schemeClr val="lt1"/>
-          </a:fontRef>
-        </p:style>
-        <p:txBody>
-          <a:bodyPr rtlCol="0" anchor="ctr"/>
-          <a:lstStyle/>
-          <a:p>
-            <a:pPr algn="ctr"/>
-            <a:endParaRPr/>
-          </a:p>
-        </p:txBody>
-      </p:sp>
-      <p:sp>
-        <p:nvSpPr>
-          <p:cNvPr id="9" name="TextBox 8"/>
-          <p:cNvSpPr txBox="1"/>
-          <p:nvPr/>
-        </p:nvSpPr>
-        <p:spPr>
-          <a:xfrm>
-            <a:off x="6583680" y="2011680"/>
-            <a:ext cx="4389120" cy="457200"/>
-          </a:xfrm>
-          <a:prstGeom prst="rect">
-            <a:avLst/>
-          </a:prstGeom>
-          <a:noFill/>
-        </p:spPr>
-        <p:txBody>
-          <a:bodyPr wrap="square">
-            <a:spAutoFit/>
-          </a:bodyPr>
-          <a:lstStyle/>
-          <a:p>
-            <a:pPr algn="l">
-              <a:defRPr sz="2000" b="1">
-                <a:solidFill>
-                  <a:srgbClr val="FB923C"/>
-                </a:solidFill>
-                <a:latin typeface="Calibri"/>
-              </a:defRPr>
-            </a:pPr>
-            <a:r>
-              <a:t>Set permissions:</a:t>
-            </a:r>
-          </a:p>
-        </p:txBody>
-      </p:sp>
-      <p:sp>
-        <p:nvSpPr>
-          <p:cNvPr id="10" name="TextBox 9"/>
-          <p:cNvSpPr txBox="1"/>
-          <p:nvPr/>
-        </p:nvSpPr>
-        <p:spPr>
-          <a:xfrm>
-            <a:off x="6583680" y="2560320"/>
-            <a:ext cx="4389120" cy="457200"/>
-          </a:xfrm>
-          <a:prstGeom prst="rect">
-            <a:avLst/>
-          </a:prstGeom>
-          <a:noFill/>
-        </p:spPr>
-        <p:txBody>
-          <a:bodyPr wrap="square">
-            <a:spAutoFit/>
-          </a:bodyPr>
-          <a:lstStyle/>
-          <a:p>
-            <a:pPr algn="l">
-              <a:defRPr sz="2800" b="1">
-                <a:solidFill>
-                  <a:srgbClr val="FB923C"/>
-                </a:solidFill>
-                <a:latin typeface="Courier New"/>
-              </a:defRPr>
-            </a:pPr>
-            <a:r>
-              <a:t>/permissions</a:t>
-            </a:r>
-          </a:p>
-        </p:txBody>
-      </p:sp>
-      <p:sp>
-        <p:nvSpPr>
-          <p:cNvPr id="11" name="TextBox 10"/>
-          <p:cNvSpPr txBox="1"/>
-          <p:nvPr/>
-        </p:nvSpPr>
-        <p:spPr>
-          <a:xfrm>
-            <a:off x="6583680" y="3200400"/>
-            <a:ext cx="4389120" cy="2743200"/>
-          </a:xfrm>
-          <a:prstGeom prst="rect">
-            <a:avLst/>
-          </a:prstGeom>
-          <a:noFill/>
-        </p:spPr>
-        <p:txBody>
-          <a:bodyPr wrap="square">
-            <a:spAutoFit/>
-          </a:bodyPr>
-          <a:lstStyle/>
-          <a:p>
-            <a:pPr algn="l">
-              <a:defRPr sz="1600" b="0">
-                <a:solidFill>
-                  <a:srgbClr val="E2E8F0"/>
-                </a:solidFill>
-                <a:latin typeface="Calibri"/>
-              </a:defRPr>
-            </a:pPr>
-            <a:r>
-              <a:t>Select "Bypass permissions" so Claude</a:t>
-            </a:r>
-            <a:br/>
-            <a:r>
-              <a:t>can run marketing workflows without</a:t>
-            </a:r>
-            <a:br/>
-            <a:r>
-              <a:t>asking to approve every API call.</a:t>
-            </a:r>
-            <a:br/>
-            <a:br/>
-            <a:r>
-              <a:t>You can also toggle with:</a:t>
-            </a:r>
-            <a:br/>
-            <a:r>
-              <a:t>Shift+Ctrl+P (Win) or Shift+Cmd+P (Mac)</a:t>
-            </a:r>
-          </a:p>
-        </p:txBody>
-      </p:sp>
-    </p:spTree>
-  </p:cSld>
-  <p:clrMapOvr>
-    <a:masterClrMapping/>
-  </p:clrMapOvr>
-</p:sld>
-</file>
-
 <file path=ppt/slides/slide9.xml><?xml version="1.0" encoding="utf-8"?>
 <p:sld xmlns:a="http://schemas.openxmlformats.org/drawingml/2006/main" xmlns:r="http://schemas.openxmlformats.org/officeDocument/2006/relationships" xmlns:p="http://schemas.openxmlformats.org/presentationml/2006/main">
   <p:cSld>
@@ -11260,7 +10821,7 @@
               </a:defRPr>
             </a:pPr>
             <a:r>
-              <a:t>Step 9</a:t>
+              <a:t>Step 7</a:t>
             </a:r>
           </a:p>
         </p:txBody>

</xml_diff>